<commit_message>
feat: implement full-stack dashboard, forecast, chat features and transaction data repository
</commit_message>
<xml_diff>
--- a/Prima-Astro-Overview.pptx
+++ b/Prima-Astro-Overview.pptx
@@ -3282,7 +3282,7 @@
               </a:spcAft>
             </a:pPr>
             <a:r>
-              <a:rPr sz="8800" b="1" i="0">
+              <a:rPr sz="8800" b="1" i="0" dirty="0">
                 <a:solidFill>
                   <a:srgbClr val="EEF1F6"/>
                 </a:solidFill>
@@ -3302,7 +3302,7 @@
         <p:spPr>
           <a:xfrm>
             <a:off x="822960" y="3794760"/>
-            <a:ext cx="8686800" cy="738920"/>
+            <a:ext cx="8686800" cy="769441"/>
           </a:xfrm>
           <a:prstGeom prst="rect">
             <a:avLst/>
@@ -3326,7 +3326,7 @@
                   <a:schemeClr val="bg1"/>
                 </a:solidFill>
               </a:rPr>
-              <a:t>Agen</a:t>
+              <a:t>Kelompok</a:t>
             </a:r>
             <a:r>
               <a:rPr lang="en-US" sz="2000" dirty="0" smtClean="0">
@@ -3334,127 +3334,30 @@
                   <a:schemeClr val="bg1"/>
                 </a:solidFill>
               </a:rPr>
-              <a:t> </a:t>
-            </a:r>
-            <a:r>
-              <a:rPr lang="en-US" sz="2000" dirty="0">
+              <a:t> 3</a:t>
+            </a:r>
+            <a:br>
+              <a:rPr lang="en-US" sz="2000" dirty="0" smtClean="0">
                 <a:solidFill>
                   <a:schemeClr val="bg1"/>
                 </a:solidFill>
               </a:rPr>
-              <a:t>AI </a:t>
-            </a:r>
-            <a:r>
-              <a:rPr lang="en-US" sz="2000" dirty="0" err="1">
+            </a:br>
+            <a:r>
+              <a:rPr lang="en-US" sz="2000" dirty="0" smtClean="0">
                 <a:solidFill>
                   <a:schemeClr val="bg1"/>
                 </a:solidFill>
               </a:rPr>
-              <a:t>Terintegrasi</a:t>
-            </a:r>
-            <a:r>
-              <a:rPr lang="en-US" sz="2000" dirty="0">
+              <a:t>David, Findryan, Jonathan, </a:t>
+            </a:r>
+            <a:r>
+              <a:rPr lang="en-US" sz="2000" dirty="0" err="1" smtClean="0">
                 <a:solidFill>
                   <a:schemeClr val="bg1"/>
                 </a:solidFill>
               </a:rPr>
-              <a:t> </a:t>
-            </a:r>
-            <a:r>
-              <a:rPr lang="en-US" sz="2000" dirty="0" err="1">
-                <a:solidFill>
-                  <a:schemeClr val="bg1"/>
-                </a:solidFill>
-              </a:rPr>
-              <a:t>untuk</a:t>
-            </a:r>
-            <a:r>
-              <a:rPr lang="en-US" sz="2000" dirty="0">
-                <a:solidFill>
-                  <a:schemeClr val="bg1"/>
-                </a:solidFill>
-              </a:rPr>
-              <a:t> </a:t>
-            </a:r>
-            <a:r>
-              <a:rPr lang="en-US" sz="2000" dirty="0" err="1">
-                <a:solidFill>
-                  <a:schemeClr val="bg1"/>
-                </a:solidFill>
-              </a:rPr>
-              <a:t>Mengoptimalkan</a:t>
-            </a:r>
-            <a:r>
-              <a:rPr lang="en-US" sz="2000" dirty="0">
-                <a:solidFill>
-                  <a:schemeClr val="bg1"/>
-                </a:solidFill>
-              </a:rPr>
-              <a:t> </a:t>
-            </a:r>
-            <a:r>
-              <a:rPr lang="en-US" sz="2000" dirty="0" err="1">
-                <a:solidFill>
-                  <a:schemeClr val="bg1"/>
-                </a:solidFill>
-              </a:rPr>
-              <a:t>Pengelolaan</a:t>
-            </a:r>
-            <a:r>
-              <a:rPr lang="en-US" sz="2000" dirty="0">
-                <a:solidFill>
-                  <a:schemeClr val="bg1"/>
-                </a:solidFill>
-              </a:rPr>
-              <a:t> Stok, </a:t>
-            </a:r>
-            <a:r>
-              <a:rPr lang="en-US" sz="2000" dirty="0" err="1">
-                <a:solidFill>
-                  <a:schemeClr val="bg1"/>
-                </a:solidFill>
-              </a:rPr>
-              <a:t>Transaksi</a:t>
-            </a:r>
-            <a:r>
-              <a:rPr lang="en-US" sz="2000" dirty="0">
-                <a:solidFill>
-                  <a:schemeClr val="bg1"/>
-                </a:solidFill>
-              </a:rPr>
-              <a:t>, </a:t>
-            </a:r>
-            <a:r>
-              <a:rPr lang="en-US" sz="2000" dirty="0" err="1">
-                <a:solidFill>
-                  <a:schemeClr val="bg1"/>
-                </a:solidFill>
-              </a:rPr>
-              <a:t>dan</a:t>
-            </a:r>
-            <a:r>
-              <a:rPr lang="en-US" sz="2000" dirty="0">
-                <a:solidFill>
-                  <a:schemeClr val="bg1"/>
-                </a:solidFill>
-              </a:rPr>
-              <a:t> </a:t>
-            </a:r>
-            <a:r>
-              <a:rPr lang="en-US" sz="2000" dirty="0" err="1">
-                <a:solidFill>
-                  <a:schemeClr val="bg1"/>
-                </a:solidFill>
-              </a:rPr>
-              <a:t>Pengadaan</a:t>
-            </a:r>
-            <a:r>
-              <a:rPr lang="en-US" sz="2000" dirty="0">
-                <a:solidFill>
-                  <a:schemeClr val="bg1"/>
-                </a:solidFill>
-              </a:rPr>
-              <a:t> Spare Part.</a:t>
+              <a:t>Ongky</a:t>
             </a:r>
             <a:endParaRPr sz="2000" b="0" i="0" dirty="0">
               <a:solidFill>
@@ -3955,12 +3858,6 @@
               </a:rPr>
               <a:t>Prima ASTRO</a:t>
             </a:r>
-            <a:endParaRPr lang="en-US" sz="1200" dirty="0">
-              <a:solidFill>
-                <a:srgbClr val="6B7488"/>
-              </a:solidFill>
-              <a:latin typeface="Consolas"/>
-            </a:endParaRPr>
           </a:p>
         </p:txBody>
       </p:sp>
@@ -5829,12 +5726,6 @@
               </a:rPr>
               <a:t>Prima ASTRO</a:t>
             </a:r>
-            <a:endParaRPr lang="en-US" sz="1200" dirty="0">
-              <a:solidFill>
-                <a:srgbClr val="6B7488"/>
-              </a:solidFill>
-              <a:latin typeface="Consolas"/>
-            </a:endParaRPr>
           </a:p>
         </p:txBody>
       </p:sp>
@@ -6706,12 +6597,6 @@
               </a:rPr>
               <a:t>Prima ASTRO</a:t>
             </a:r>
-            <a:endParaRPr lang="en-US" sz="1200" dirty="0">
-              <a:solidFill>
-                <a:srgbClr val="6B7488"/>
-              </a:solidFill>
-              <a:latin typeface="Consolas"/>
-            </a:endParaRPr>
           </a:p>
         </p:txBody>
       </p:sp>
@@ -7761,12 +7646,6 @@
               </a:rPr>
               <a:t>Prima ASTRO</a:t>
             </a:r>
-            <a:endParaRPr lang="en-US" sz="1200" dirty="0">
-              <a:solidFill>
-                <a:srgbClr val="6B7488"/>
-              </a:solidFill>
-              <a:latin typeface="Consolas"/>
-            </a:endParaRPr>
           </a:p>
         </p:txBody>
       </p:sp>

</xml_diff>